<commit_message>
last update before changing design
</commit_message>
<xml_diff>
--- a/מצגת1.pptx
+++ b/מצגת1.pptx
@@ -106,6 +106,11 @@
       </a:defRPr>
     </a:lvl9pPr>
   </p:defaultTextStyle>
+  <p:extLst>
+    <p:ext uri="{EFAFB233-063F-42B5-8137-9DF3F51BA10A}">
+      <p15:sldGuideLst xmlns:p15="http://schemas.microsoft.com/office/powerpoint/2012/main"/>
+    </p:ext>
+  </p:extLst>
 </p:presentation>
 </file>
 
@@ -258,7 +263,7 @@
           <a:p>
             <a:fld id="{5463C80B-6E72-46B6-88A1-B9915FF9596B}" type="datetimeFigureOut">
               <a:rPr lang="en-US" smtClean="0"/>
-              <a:t>4/5/2026</a:t>
+              <a:t>4/14/2026</a:t>
             </a:fld>
             <a:endParaRPr lang="en-US"/>
           </a:p>
@@ -458,7 +463,7 @@
           <a:p>
             <a:fld id="{5463C80B-6E72-46B6-88A1-B9915FF9596B}" type="datetimeFigureOut">
               <a:rPr lang="en-US" smtClean="0"/>
-              <a:t>4/5/2026</a:t>
+              <a:t>4/14/2026</a:t>
             </a:fld>
             <a:endParaRPr lang="en-US"/>
           </a:p>
@@ -668,7 +673,7 @@
           <a:p>
             <a:fld id="{5463C80B-6E72-46B6-88A1-B9915FF9596B}" type="datetimeFigureOut">
               <a:rPr lang="en-US" smtClean="0"/>
-              <a:t>4/5/2026</a:t>
+              <a:t>4/14/2026</a:t>
             </a:fld>
             <a:endParaRPr lang="en-US"/>
           </a:p>
@@ -868,7 +873,7 @@
           <a:p>
             <a:fld id="{5463C80B-6E72-46B6-88A1-B9915FF9596B}" type="datetimeFigureOut">
               <a:rPr lang="en-US" smtClean="0"/>
-              <a:t>4/5/2026</a:t>
+              <a:t>4/14/2026</a:t>
             </a:fld>
             <a:endParaRPr lang="en-US"/>
           </a:p>
@@ -1144,7 +1149,7 @@
           <a:p>
             <a:fld id="{5463C80B-6E72-46B6-88A1-B9915FF9596B}" type="datetimeFigureOut">
               <a:rPr lang="en-US" smtClean="0"/>
-              <a:t>4/5/2026</a:t>
+              <a:t>4/14/2026</a:t>
             </a:fld>
             <a:endParaRPr lang="en-US"/>
           </a:p>
@@ -1412,7 +1417,7 @@
           <a:p>
             <a:fld id="{5463C80B-6E72-46B6-88A1-B9915FF9596B}" type="datetimeFigureOut">
               <a:rPr lang="en-US" smtClean="0"/>
-              <a:t>4/5/2026</a:t>
+              <a:t>4/14/2026</a:t>
             </a:fld>
             <a:endParaRPr lang="en-US"/>
           </a:p>
@@ -1827,7 +1832,7 @@
           <a:p>
             <a:fld id="{5463C80B-6E72-46B6-88A1-B9915FF9596B}" type="datetimeFigureOut">
               <a:rPr lang="en-US" smtClean="0"/>
-              <a:t>4/5/2026</a:t>
+              <a:t>4/14/2026</a:t>
             </a:fld>
             <a:endParaRPr lang="en-US"/>
           </a:p>
@@ -1969,7 +1974,7 @@
           <a:p>
             <a:fld id="{5463C80B-6E72-46B6-88A1-B9915FF9596B}" type="datetimeFigureOut">
               <a:rPr lang="en-US" smtClean="0"/>
-              <a:t>4/5/2026</a:t>
+              <a:t>4/14/2026</a:t>
             </a:fld>
             <a:endParaRPr lang="en-US"/>
           </a:p>
@@ -2082,7 +2087,7 @@
           <a:p>
             <a:fld id="{5463C80B-6E72-46B6-88A1-B9915FF9596B}" type="datetimeFigureOut">
               <a:rPr lang="en-US" smtClean="0"/>
-              <a:t>4/5/2026</a:t>
+              <a:t>4/14/2026</a:t>
             </a:fld>
             <a:endParaRPr lang="en-US"/>
           </a:p>
@@ -2395,7 +2400,7 @@
           <a:p>
             <a:fld id="{5463C80B-6E72-46B6-88A1-B9915FF9596B}" type="datetimeFigureOut">
               <a:rPr lang="en-US" smtClean="0"/>
-              <a:t>4/5/2026</a:t>
+              <a:t>4/14/2026</a:t>
             </a:fld>
             <a:endParaRPr lang="en-US"/>
           </a:p>
@@ -2684,7 +2689,7 @@
           <a:p>
             <a:fld id="{5463C80B-6E72-46B6-88A1-B9915FF9596B}" type="datetimeFigureOut">
               <a:rPr lang="en-US" smtClean="0"/>
-              <a:t>4/5/2026</a:t>
+              <a:t>4/14/2026</a:t>
             </a:fld>
             <a:endParaRPr lang="en-US"/>
           </a:p>
@@ -2927,7 +2932,7 @@
           <a:p>
             <a:fld id="{5463C80B-6E72-46B6-88A1-B9915FF9596B}" type="datetimeFigureOut">
               <a:rPr lang="en-US" smtClean="0"/>
-              <a:t>4/5/2026</a:t>
+              <a:t>4/14/2026</a:t>
             </a:fld>
             <a:endParaRPr lang="en-US"/>
           </a:p>
@@ -3836,6 +3841,253 @@
           </a:fontRef>
         </p:style>
       </p:cxnSp>
+      <p:cxnSp>
+        <p:nvCxnSpPr>
+          <p:cNvPr id="2" name="מחבר חץ ישר 1">
+            <a:extLst>
+              <a:ext uri="{FF2B5EF4-FFF2-40B4-BE49-F238E27FC236}">
+                <a16:creationId xmlns:a16="http://schemas.microsoft.com/office/drawing/2014/main" id="{128BB797-FC57-A765-48B8-B7613289E96F}"/>
+              </a:ext>
+            </a:extLst>
+          </p:cNvPr>
+          <p:cNvCxnSpPr>
+            <a:cxnSpLocks/>
+          </p:cNvCxnSpPr>
+          <p:nvPr/>
+        </p:nvCxnSpPr>
+        <p:spPr>
+          <a:xfrm flipV="1">
+            <a:off x="9717223" y="3543300"/>
+            <a:ext cx="24131" cy="1264830"/>
+          </a:xfrm>
+          <a:prstGeom prst="straightConnector1">
+            <a:avLst/>
+          </a:prstGeom>
+          <a:ln>
+            <a:tailEnd type="triangle"/>
+          </a:ln>
+        </p:spPr>
+        <p:style>
+          <a:lnRef idx="2">
+            <a:schemeClr val="accent1"/>
+          </a:lnRef>
+          <a:fillRef idx="0">
+            <a:schemeClr val="accent1"/>
+          </a:fillRef>
+          <a:effectRef idx="1">
+            <a:schemeClr val="accent1"/>
+          </a:effectRef>
+          <a:fontRef idx="minor">
+            <a:schemeClr val="tx1"/>
+          </a:fontRef>
+        </p:style>
+      </p:cxnSp>
+      <p:sp>
+        <p:nvSpPr>
+          <p:cNvPr id="3" name="תיבת טקסט 2">
+            <a:extLst>
+              <a:ext uri="{FF2B5EF4-FFF2-40B4-BE49-F238E27FC236}">
+                <a16:creationId xmlns:a16="http://schemas.microsoft.com/office/drawing/2014/main" id="{107A91B8-D77A-B6B8-4CD5-F8E32CA190C6}"/>
+              </a:ext>
+            </a:extLst>
+          </p:cNvPr>
+          <p:cNvSpPr txBox="1"/>
+          <p:nvPr/>
+        </p:nvSpPr>
+        <p:spPr>
+          <a:xfrm>
+            <a:off x="8831126" y="5236811"/>
+            <a:ext cx="2089150" cy="369332"/>
+          </a:xfrm>
+          <a:prstGeom prst="rect">
+            <a:avLst/>
+          </a:prstGeom>
+          <a:noFill/>
+          <a:ln>
+            <a:solidFill>
+              <a:schemeClr val="tx1"/>
+            </a:solidFill>
+          </a:ln>
+        </p:spPr>
+        <p:txBody>
+          <a:bodyPr wrap="square" rtlCol="0">
+            <a:spAutoFit/>
+          </a:bodyPr>
+          <a:lstStyle/>
+          <a:p>
+            <a:pPr algn="l" rtl="0"/>
+            <a:r>
+              <a:rPr lang="en-US" dirty="0"/>
+              <a:t>Fine tuning</a:t>
+            </a:r>
+          </a:p>
+        </p:txBody>
+      </p:sp>
+      <p:cxnSp>
+        <p:nvCxnSpPr>
+          <p:cNvPr id="8" name="מחבר חץ ישר 7">
+            <a:extLst>
+              <a:ext uri="{FF2B5EF4-FFF2-40B4-BE49-F238E27FC236}">
+                <a16:creationId xmlns:a16="http://schemas.microsoft.com/office/drawing/2014/main" id="{D96B37F4-7700-F666-7131-0D1D6EDE4E1E}"/>
+              </a:ext>
+            </a:extLst>
+          </p:cNvPr>
+          <p:cNvCxnSpPr>
+            <a:cxnSpLocks/>
+          </p:cNvCxnSpPr>
+          <p:nvPr/>
+        </p:nvCxnSpPr>
+        <p:spPr>
+          <a:xfrm flipV="1">
+            <a:off x="5783897" y="3701233"/>
+            <a:ext cx="24131" cy="1264830"/>
+          </a:xfrm>
+          <a:prstGeom prst="straightConnector1">
+            <a:avLst/>
+          </a:prstGeom>
+          <a:ln>
+            <a:tailEnd type="triangle"/>
+          </a:ln>
+        </p:spPr>
+        <p:style>
+          <a:lnRef idx="2">
+            <a:schemeClr val="accent1"/>
+          </a:lnRef>
+          <a:fillRef idx="0">
+            <a:schemeClr val="accent1"/>
+          </a:fillRef>
+          <a:effectRef idx="1">
+            <a:schemeClr val="accent1"/>
+          </a:effectRef>
+          <a:fontRef idx="minor">
+            <a:schemeClr val="tx1"/>
+          </a:fontRef>
+        </p:style>
+      </p:cxnSp>
+      <p:sp>
+        <p:nvSpPr>
+          <p:cNvPr id="10" name="תיבת טקסט 9">
+            <a:extLst>
+              <a:ext uri="{FF2B5EF4-FFF2-40B4-BE49-F238E27FC236}">
+                <a16:creationId xmlns:a16="http://schemas.microsoft.com/office/drawing/2014/main" id="{FFF45A57-5947-1765-0475-2BE0D2D4DE66}"/>
+              </a:ext>
+            </a:extLst>
+          </p:cNvPr>
+          <p:cNvSpPr txBox="1"/>
+          <p:nvPr/>
+        </p:nvSpPr>
+        <p:spPr>
+          <a:xfrm>
+            <a:off x="4919526" y="5162034"/>
+            <a:ext cx="2089150" cy="646331"/>
+          </a:xfrm>
+          <a:prstGeom prst="rect">
+            <a:avLst/>
+          </a:prstGeom>
+          <a:noFill/>
+          <a:ln>
+            <a:solidFill>
+              <a:schemeClr val="tx1"/>
+            </a:solidFill>
+          </a:ln>
+        </p:spPr>
+        <p:txBody>
+          <a:bodyPr wrap="square" rtlCol="0">
+            <a:spAutoFit/>
+          </a:bodyPr>
+          <a:lstStyle/>
+          <a:p>
+            <a:pPr algn="l" rtl="0"/>
+            <a:r>
+              <a:rPr lang="en-US" dirty="0"/>
+              <a:t>RAG and embedding</a:t>
+            </a:r>
+          </a:p>
+        </p:txBody>
+      </p:sp>
+      <p:cxnSp>
+        <p:nvCxnSpPr>
+          <p:cNvPr id="12" name="מחבר חץ ישר 11">
+            <a:extLst>
+              <a:ext uri="{FF2B5EF4-FFF2-40B4-BE49-F238E27FC236}">
+                <a16:creationId xmlns:a16="http://schemas.microsoft.com/office/drawing/2014/main" id="{29FB5E05-705D-7FDA-D0B7-9705CBAC534D}"/>
+              </a:ext>
+            </a:extLst>
+          </p:cNvPr>
+          <p:cNvCxnSpPr>
+            <a:cxnSpLocks/>
+          </p:cNvCxnSpPr>
+          <p:nvPr/>
+        </p:nvCxnSpPr>
+        <p:spPr>
+          <a:xfrm>
+            <a:off x="1921782" y="5743122"/>
+            <a:ext cx="0" cy="403678"/>
+          </a:xfrm>
+          <a:prstGeom prst="straightConnector1">
+            <a:avLst/>
+          </a:prstGeom>
+          <a:ln>
+            <a:tailEnd type="triangle"/>
+          </a:ln>
+        </p:spPr>
+        <p:style>
+          <a:lnRef idx="2">
+            <a:schemeClr val="accent1"/>
+          </a:lnRef>
+          <a:fillRef idx="0">
+            <a:schemeClr val="accent1"/>
+          </a:fillRef>
+          <a:effectRef idx="1">
+            <a:schemeClr val="accent1"/>
+          </a:effectRef>
+          <a:fontRef idx="minor">
+            <a:schemeClr val="tx1"/>
+          </a:fontRef>
+        </p:style>
+      </p:cxnSp>
+      <p:sp>
+        <p:nvSpPr>
+          <p:cNvPr id="15" name="תיבת טקסט 14">
+            <a:extLst>
+              <a:ext uri="{FF2B5EF4-FFF2-40B4-BE49-F238E27FC236}">
+                <a16:creationId xmlns:a16="http://schemas.microsoft.com/office/drawing/2014/main" id="{009EB6A9-0B71-EF7F-67B8-FD88EA8A54C5}"/>
+              </a:ext>
+            </a:extLst>
+          </p:cNvPr>
+          <p:cNvSpPr txBox="1"/>
+          <p:nvPr/>
+        </p:nvSpPr>
+        <p:spPr>
+          <a:xfrm>
+            <a:off x="779326" y="6283779"/>
+            <a:ext cx="2089150" cy="369332"/>
+          </a:xfrm>
+          <a:prstGeom prst="rect">
+            <a:avLst/>
+          </a:prstGeom>
+          <a:noFill/>
+          <a:ln>
+            <a:solidFill>
+              <a:schemeClr val="tx1"/>
+            </a:solidFill>
+          </a:ln>
+        </p:spPr>
+        <p:txBody>
+          <a:bodyPr wrap="square" rtlCol="0">
+            <a:spAutoFit/>
+          </a:bodyPr>
+          <a:lstStyle/>
+          <a:p>
+            <a:pPr algn="l" rtl="0"/>
+            <a:r>
+              <a:rPr lang="en-US" dirty="0" err="1"/>
+              <a:t>DB_Tech</a:t>
+            </a:r>
+            <a:endParaRPr lang="en-US" dirty="0"/>
+          </a:p>
+        </p:txBody>
+      </p:sp>
     </p:spTree>
     <p:extLst>
       <p:ext uri="{BB962C8B-B14F-4D97-AF65-F5344CB8AC3E}">

</xml_diff>